<commit_message>
docs: add survey findings slide and update title slide for presentation
</commit_message>
<xml_diff>
--- a/docs/presentation/file-3/slide-01-title.pptx
+++ b/docs/presentation/file-3/slide-01-title.pptx
@@ -10,8 +10,8 @@
   <p:notesMasterIdLst>
     <p:notesMasterId r:id="rId3"/>
   </p:notesMasterIdLst>
-  <p:sldSz cx="9144000" cy="5143500"/>
-  <p:notesSz cx="5143500" cy="9144000"/>
+  <p:sldSz cx="12192000" cy="6858000"/>
+  <p:notesSz cx="6858000" cy="12192000"/>
   <p:defaultTextStyle>
     <a:lvl1pPr marL="0" algn="l" defTabSz="914400" rtl="0" eaLnBrk="1" latinLnBrk="0" hangingPunct="1">
       <a:defRPr sz="1800" kern="1200">
@@ -875,9 +875,29 @@
           <a:chExt cx="0" cy="0"/>
         </a:xfrm>
       </p:grpSpPr>
+      <p:sp>
+        <p:nvSpPr>
+          <p:cNvPr id="2" name="Shape 0"/>
+          <p:cNvSpPr/>
+          <p:nvPr/>
+        </p:nvSpPr>
+        <p:spPr>
+          <a:xfrm>
+            <a:off x="0" y="0"/>
+            <a:ext cx="76200" cy="6858000"/>
+          </a:xfrm>
+          <a:prstGeom prst="rect">
+            <a:avLst/>
+          </a:prstGeom>
+          <a:solidFill>
+            <a:srgbClr val="8B1A1A"/>
+          </a:solidFill>
+          <a:ln/>
+        </p:spPr>
+      </p:sp>
       <p:pic>
         <p:nvPicPr>
-          <p:cNvPr id="2" name="Image 0" descr="slide-01.png">    </p:cNvPr>
+          <p:cNvPr id="3" name="Image 0" descr="/home/claude/logo-university.png">    </p:cNvPr>
           <p:cNvPicPr>
             <a:picLocks noChangeAspect="1"/>
           </p:cNvPicPr>
@@ -891,14 +911,1103 @@
         </p:blipFill>
         <p:spPr>
           <a:xfrm>
-            <a:off x="0" y="0"/>
-            <a:ext cx="9144000" cy="5143500"/>
+            <a:off x="457200" y="381000"/>
+            <a:ext cx="386169" cy="495300"/>
           </a:xfrm>
           <a:prstGeom prst="rect">
             <a:avLst/>
           </a:prstGeom>
         </p:spPr>
       </p:pic>
+      <p:sp>
+        <p:nvSpPr>
+          <p:cNvPr id="4" name="Text 1"/>
+          <p:cNvSpPr txBox="1"/>
+          <p:nvPr/>
+        </p:nvSpPr>
+        <p:spPr>
+          <a:xfrm>
+            <a:off x="76200" y="762000"/>
+            <a:ext cx="12115800" cy="190500"/>
+          </a:xfrm>
+          <a:prstGeom prst="rect">
+            <a:avLst/>
+          </a:prstGeom>
+          <a:noFill/>
+          <a:ln/>
+        </p:spPr>
+        <p:txBody>
+          <a:bodyPr wrap="square" lIns="0" tIns="0" rIns="0" bIns="0" rtlCol="0" anchor="ctr"/>
+          <a:lstStyle/>
+          <a:p>
+            <a:pPr algn="ctr" indent="0" marL="0">
+              <a:buNone/>
+            </a:pPr>
+            <a:r>
+              <a:rPr lang="en-US" sz="1150" b="1" spc="120" kern="0" dirty="0">
+                <a:solidFill>
+                  <a:srgbClr val="6B6B7A"/>
+                </a:solidFill>
+                <a:latin typeface="Calibri" pitchFamily="34" charset="0"/>
+                <a:ea typeface="Calibri" pitchFamily="34" charset="-122"/>
+                <a:cs typeface="Calibri" pitchFamily="34" charset="-120"/>
+              </a:rPr>
+              <a:t>PROFESSIONAL MASTERS IN INFORMATION AND CYBER SECURITY (PMICS)</a:t>
+            </a:r>
+            <a:endParaRPr lang="en-US" sz="1150" dirty="0"/>
+          </a:p>
+        </p:txBody>
+      </p:sp>
+      <p:sp>
+        <p:nvSpPr>
+          <p:cNvPr id="5" name="Text 2"/>
+          <p:cNvSpPr txBox="1"/>
+          <p:nvPr/>
+        </p:nvSpPr>
+        <p:spPr>
+          <a:xfrm>
+            <a:off x="76200" y="990600"/>
+            <a:ext cx="12115800" cy="171450"/>
+          </a:xfrm>
+          <a:prstGeom prst="rect">
+            <a:avLst/>
+          </a:prstGeom>
+          <a:noFill/>
+          <a:ln/>
+        </p:spPr>
+        <p:txBody>
+          <a:bodyPr wrap="square" lIns="0" tIns="0" rIns="0" bIns="0" rtlCol="0" anchor="ctr"/>
+          <a:lstStyle/>
+          <a:p>
+            <a:pPr algn="ctr" indent="0" marL="0">
+              <a:buNone/>
+            </a:pPr>
+            <a:r>
+              <a:rPr lang="en-US" sz="1100" b="1" spc="180" kern="0" dirty="0">
+                <a:solidFill>
+                  <a:srgbClr val="2E4A7A"/>
+                </a:solidFill>
+                <a:latin typeface="Courier New" pitchFamily="34" charset="0"/>
+                <a:ea typeface="Courier New" pitchFamily="34" charset="-122"/>
+                <a:cs typeface="Courier New" pitchFamily="34" charset="-120"/>
+              </a:rPr>
+              <a:t>PROJECT ON CYBER SECURITY</a:t>
+            </a:r>
+            <a:endParaRPr lang="en-US" sz="1100" dirty="0"/>
+          </a:p>
+        </p:txBody>
+      </p:sp>
+      <p:sp>
+        <p:nvSpPr>
+          <p:cNvPr id="6" name="Shape 3"/>
+          <p:cNvSpPr/>
+          <p:nvPr/>
+        </p:nvSpPr>
+        <p:spPr>
+          <a:xfrm>
+            <a:off x="4619625" y="1238250"/>
+            <a:ext cx="2952750" cy="247650"/>
+          </a:xfrm>
+          <a:prstGeom prst="roundRect">
+            <a:avLst>
+              <a:gd name="adj" fmla="val 14769"/>
+            </a:avLst>
+          </a:prstGeom>
+          <a:solidFill>
+            <a:srgbClr val="F2EAD9"/>
+          </a:solidFill>
+          <a:ln/>
+        </p:spPr>
+      </p:sp>
+      <p:sp>
+        <p:nvSpPr>
+          <p:cNvPr id="7" name="Text 4"/>
+          <p:cNvSpPr txBox="1"/>
+          <p:nvPr/>
+        </p:nvSpPr>
+        <p:spPr>
+          <a:xfrm>
+            <a:off x="4619625" y="1238250"/>
+            <a:ext cx="2952750" cy="247650"/>
+          </a:xfrm>
+          <a:prstGeom prst="rect">
+            <a:avLst/>
+          </a:prstGeom>
+          <a:noFill/>
+          <a:ln/>
+        </p:spPr>
+        <p:txBody>
+          <a:bodyPr wrap="square" lIns="0" tIns="0" rIns="0" bIns="0" rtlCol="0" anchor="ctr"/>
+          <a:lstStyle/>
+          <a:p>
+            <a:pPr algn="ctr" indent="0" marL="0">
+              <a:buNone/>
+            </a:pPr>
+            <a:r>
+              <a:rPr lang="en-US" sz="950" b="1" spc="120" kern="0" dirty="0">
+                <a:solidFill>
+                  <a:srgbClr val="7A4F1A"/>
+                </a:solidFill>
+                <a:latin typeface="Calibri" pitchFamily="34" charset="0"/>
+                <a:ea typeface="Calibri" pitchFamily="34" charset="-122"/>
+                <a:cs typeface="Calibri" pitchFamily="34" charset="-120"/>
+              </a:rPr>
+              <a:t>INCEPTION STAGE  ·  SEPTEMBER 2026</a:t>
+            </a:r>
+            <a:endParaRPr lang="en-US" sz="950" dirty="0"/>
+          </a:p>
+        </p:txBody>
+      </p:sp>
+      <p:sp>
+        <p:nvSpPr>
+          <p:cNvPr id="8" name="Text 5"/>
+          <p:cNvSpPr txBox="1"/>
+          <p:nvPr/>
+        </p:nvSpPr>
+        <p:spPr>
+          <a:xfrm>
+            <a:off x="76200" y="1752600"/>
+            <a:ext cx="12115800" cy="857250"/>
+          </a:xfrm>
+          <a:prstGeom prst="rect">
+            <a:avLst/>
+          </a:prstGeom>
+          <a:noFill/>
+          <a:ln/>
+        </p:spPr>
+        <p:txBody>
+          <a:bodyPr wrap="square" lIns="0" tIns="0" rIns="0" bIns="0" rtlCol="0" anchor="ctr"/>
+          <a:lstStyle/>
+          <a:p>
+            <a:pPr algn="ctr" indent="0" marL="0">
+              <a:buNone/>
+            </a:pPr>
+            <a:r>
+              <a:rPr lang="en-US" sz="6000" b="1" dirty="0">
+                <a:solidFill>
+                  <a:srgbClr val="8B1A1A"/>
+                </a:solidFill>
+                <a:latin typeface="Cambria" pitchFamily="34" charset="0"/>
+                <a:ea typeface="Cambria" pitchFamily="34" charset="-122"/>
+                <a:cs typeface="Cambria" pitchFamily="34" charset="-120"/>
+              </a:rPr>
+              <a:t>RedGrid</a:t>
+            </a:r>
+            <a:endParaRPr lang="en-US" sz="6000" dirty="0"/>
+          </a:p>
+        </p:txBody>
+      </p:sp>
+      <p:sp>
+        <p:nvSpPr>
+          <p:cNvPr id="9" name="Shape 6"/>
+          <p:cNvSpPr/>
+          <p:nvPr/>
+        </p:nvSpPr>
+        <p:spPr>
+          <a:xfrm>
+            <a:off x="4381500" y="2686050"/>
+            <a:ext cx="3429000" cy="0"/>
+          </a:xfrm>
+          <a:prstGeom prst="line">
+            <a:avLst/>
+          </a:prstGeom>
+          <a:noFill/>
+          <a:ln w="19050">
+            <a:solidFill>
+              <a:srgbClr val="D4CFC8"/>
+            </a:solidFill>
+            <a:prstDash val="solid"/>
+          </a:ln>
+        </p:spPr>
+      </p:sp>
+      <p:sp>
+        <p:nvSpPr>
+          <p:cNvPr id="10" name="Text 7"/>
+          <p:cNvSpPr txBox="1"/>
+          <p:nvPr/>
+        </p:nvSpPr>
+        <p:spPr>
+          <a:xfrm>
+            <a:off x="381000" y="2819400"/>
+            <a:ext cx="11430000" cy="571500"/>
+          </a:xfrm>
+          <a:prstGeom prst="rect">
+            <a:avLst/>
+          </a:prstGeom>
+          <a:noFill/>
+          <a:ln/>
+        </p:spPr>
+        <p:txBody>
+          <a:bodyPr wrap="square" lIns="0" tIns="0" rIns="0" bIns="0" rtlCol="0" anchor="ctr"/>
+          <a:lstStyle/>
+          <a:p>
+            <a:pPr algn="ctr" indent="0" marL="0">
+              <a:buNone/>
+            </a:pPr>
+            <a:r>
+              <a:rPr lang="en-US" sz="1900" dirty="0">
+                <a:solidFill>
+                  <a:srgbClr val="2E4A7A"/>
+                </a:solidFill>
+                <a:latin typeface="Calibri" pitchFamily="34" charset="0"/>
+                <a:ea typeface="Calibri" pitchFamily="34" charset="-122"/>
+                <a:cs typeface="Calibri" pitchFamily="34" charset="-120"/>
+              </a:rPr>
+              <a:t>Dependency-Constrained UCB Exploration for Autonomous Penetration Testing</a:t>
+            </a:r>
+            <a:endParaRPr lang="en-US" sz="1900" dirty="0"/>
+          </a:p>
+        </p:txBody>
+      </p:sp>
+      <p:sp>
+        <p:nvSpPr>
+          <p:cNvPr id="11" name="Text 8"/>
+          <p:cNvSpPr txBox="1"/>
+          <p:nvPr/>
+        </p:nvSpPr>
+        <p:spPr>
+          <a:xfrm>
+            <a:off x="76200" y="3638550"/>
+            <a:ext cx="12115800" cy="152400"/>
+          </a:xfrm>
+          <a:prstGeom prst="rect">
+            <a:avLst/>
+          </a:prstGeom>
+          <a:noFill/>
+          <a:ln/>
+        </p:spPr>
+        <p:txBody>
+          <a:bodyPr wrap="square" lIns="0" tIns="0" rIns="0" bIns="0" rtlCol="0" anchor="ctr"/>
+          <a:lstStyle/>
+          <a:p>
+            <a:pPr algn="ctr" indent="0" marL="0">
+              <a:buNone/>
+            </a:pPr>
+            <a:r>
+              <a:rPr lang="en-US" sz="900" b="1" spc="150" kern="0" dirty="0">
+                <a:solidFill>
+                  <a:srgbClr val="9A9AAA"/>
+                </a:solidFill>
+                <a:latin typeface="Calibri" pitchFamily="34" charset="0"/>
+                <a:ea typeface="Calibri" pitchFamily="34" charset="-122"/>
+                <a:cs typeface="Calibri" pitchFamily="34" charset="-120"/>
+              </a:rPr>
+              <a:t>PRESENTED BY</a:t>
+            </a:r>
+            <a:endParaRPr lang="en-US" sz="900" dirty="0"/>
+          </a:p>
+        </p:txBody>
+      </p:sp>
+      <p:graphicFrame>
+        <p:nvGraphicFramePr>
+          <p:cNvPr id="2" name="Table 0"/>
+          <p:cNvGraphicFramePr>
+            <a:graphicFrameLocks noGrp="1"/>
+          </p:cNvGraphicFramePr>
+          <p:nvPr>
+            <p:extLst>
+              <p:ext uri="{D42A27DB-BD31-4B8C-83A1-F6EECF244321}">
+                <p14:modId xmlns:p14="http://schemas.microsoft.com/office/powerpoint/2010/main" val="1579011935"/>
+              </p:ext>
+            </p:extLst>
+          </p:nvPr>
+        </p:nvGraphicFramePr>
+        <p:xfrm>
+          <a:off x="4000500" y="3905250"/>
+          <a:ext cx="4191000" cy="914400"/>
+        </p:xfrm>
+        <a:graphic>
+          <a:graphicData uri="http://schemas.openxmlformats.org/drawingml/2006/table">
+            <a:tbl>
+              <a:tblPr/>
+              <a:tblGrid>
+                <a:gridCol w="2095500"/>
+                <a:gridCol w="1047750"/>
+                <a:gridCol w="1047750"/>
+              </a:tblGrid>
+              <a:tr h="228600">
+                <a:tc>
+                  <a:txBody>
+                    <a:bodyPr/>
+                    <a:lstStyle/>
+                    <a:p>
+                      <a:pPr algn="ctr" indent="0" marL="0">
+                        <a:buNone/>
+                      </a:pPr>
+                      <a:r>
+                        <a:rPr lang="en-US" sz="900" b="1" dirty="0">
+                          <a:solidFill>
+                            <a:srgbClr val="9A9AAA"/>
+                          </a:solidFill>
+                        </a:rPr>
+                        <a:t>Name</a:t>
+                      </a:r>
+                      <a:endParaRPr lang="en-US" sz="900" dirty="0"/>
+                    </a:p>
+                  </a:txBody>
+                  <a:tcPr marL="91440" marR="91440" marT="45720" marB="45720" anchor="ctr">
+                    <a:lnL w="9525" cap="flat" cmpd="sng" algn="ctr">
+                      <a:solidFill>
+                        <a:srgbClr val="D4CFC8"/>
+                      </a:solidFill>
+                      <a:prstDash val="solid"/>
+                      <a:round/>
+                      <a:headEnd type="none" w="med" len="med"/>
+                      <a:tailEnd type="none" w="med" len="med"/>
+                    </a:lnL>
+                    <a:lnR w="9525" cap="flat" cmpd="sng" algn="ctr">
+                      <a:solidFill>
+                        <a:srgbClr val="D4CFC8"/>
+                      </a:solidFill>
+                      <a:prstDash val="solid"/>
+                      <a:round/>
+                      <a:headEnd type="none" w="med" len="med"/>
+                      <a:tailEnd type="none" w="med" len="med"/>
+                    </a:lnR>
+                    <a:lnT w="9525" cap="flat" cmpd="sng" algn="ctr">
+                      <a:solidFill>
+                        <a:srgbClr val="D4CFC8"/>
+                      </a:solidFill>
+                      <a:prstDash val="solid"/>
+                      <a:round/>
+                      <a:headEnd type="none" w="med" len="med"/>
+                      <a:tailEnd type="none" w="med" len="med"/>
+                    </a:lnT>
+                    <a:lnB w="9525" cap="flat" cmpd="sng" algn="ctr">
+                      <a:solidFill>
+                        <a:srgbClr val="D4CFC8"/>
+                      </a:solidFill>
+                      <a:prstDash val="solid"/>
+                      <a:round/>
+                      <a:headEnd type="none" w="med" len="med"/>
+                      <a:tailEnd type="none" w="med" len="med"/>
+                    </a:lnB>
+                    <a:solidFill>
+                      <a:srgbClr val="F7F4EF"/>
+                    </a:solidFill>
+                  </a:tcPr>
+                </a:tc>
+                <a:tc>
+                  <a:txBody>
+                    <a:bodyPr/>
+                    <a:lstStyle/>
+                    <a:p>
+                      <a:pPr algn="ctr" indent="0" marL="0">
+                        <a:buNone/>
+                      </a:pPr>
+                      <a:r>
+                        <a:rPr lang="en-US" sz="900" b="1" dirty="0">
+                          <a:solidFill>
+                            <a:srgbClr val="9A9AAA"/>
+                          </a:solidFill>
+                        </a:rPr>
+                        <a:t>Class Roll</a:t>
+                      </a:r>
+                      <a:endParaRPr lang="en-US" sz="900" dirty="0"/>
+                    </a:p>
+                  </a:txBody>
+                  <a:tcPr marL="91440" marR="91440" marT="45720" marB="45720" anchor="ctr">
+                    <a:lnL w="9525" cap="flat" cmpd="sng" algn="ctr">
+                      <a:solidFill>
+                        <a:srgbClr val="D4CFC8"/>
+                      </a:solidFill>
+                      <a:prstDash val="solid"/>
+                      <a:round/>
+                      <a:headEnd type="none" w="med" len="med"/>
+                      <a:tailEnd type="none" w="med" len="med"/>
+                    </a:lnL>
+                    <a:lnR w="9525" cap="flat" cmpd="sng" algn="ctr">
+                      <a:solidFill>
+                        <a:srgbClr val="D4CFC8"/>
+                      </a:solidFill>
+                      <a:prstDash val="solid"/>
+                      <a:round/>
+                      <a:headEnd type="none" w="med" len="med"/>
+                      <a:tailEnd type="none" w="med" len="med"/>
+                    </a:lnR>
+                    <a:lnT w="9525" cap="flat" cmpd="sng" algn="ctr">
+                      <a:solidFill>
+                        <a:srgbClr val="D4CFC8"/>
+                      </a:solidFill>
+                      <a:prstDash val="solid"/>
+                      <a:round/>
+                      <a:headEnd type="none" w="med" len="med"/>
+                      <a:tailEnd type="none" w="med" len="med"/>
+                    </a:lnT>
+                    <a:lnB w="9525" cap="flat" cmpd="sng" algn="ctr">
+                      <a:solidFill>
+                        <a:srgbClr val="D4CFC8"/>
+                      </a:solidFill>
+                      <a:prstDash val="solid"/>
+                      <a:round/>
+                      <a:headEnd type="none" w="med" len="med"/>
+                      <a:tailEnd type="none" w="med" len="med"/>
+                    </a:lnB>
+                    <a:solidFill>
+                      <a:srgbClr val="F7F4EF"/>
+                    </a:solidFill>
+                  </a:tcPr>
+                </a:tc>
+                <a:tc>
+                  <a:txBody>
+                    <a:bodyPr/>
+                    <a:lstStyle/>
+                    <a:p>
+                      <a:pPr algn="ctr" indent="0" marL="0">
+                        <a:buNone/>
+                      </a:pPr>
+                      <a:r>
+                        <a:rPr lang="en-US" sz="900" b="1" dirty="0">
+                          <a:solidFill>
+                            <a:srgbClr val="9A9AAA"/>
+                          </a:solidFill>
+                        </a:rPr>
+                        <a:t>Reg No</a:t>
+                      </a:r>
+                      <a:endParaRPr lang="en-US" sz="900" dirty="0"/>
+                    </a:p>
+                  </a:txBody>
+                  <a:tcPr marL="91440" marR="91440" marT="45720" marB="45720" anchor="ctr">
+                    <a:lnL w="9525" cap="flat" cmpd="sng" algn="ctr">
+                      <a:solidFill>
+                        <a:srgbClr val="D4CFC8"/>
+                      </a:solidFill>
+                      <a:prstDash val="solid"/>
+                      <a:round/>
+                      <a:headEnd type="none" w="med" len="med"/>
+                      <a:tailEnd type="none" w="med" len="med"/>
+                    </a:lnL>
+                    <a:lnR w="9525" cap="flat" cmpd="sng" algn="ctr">
+                      <a:solidFill>
+                        <a:srgbClr val="D4CFC8"/>
+                      </a:solidFill>
+                      <a:prstDash val="solid"/>
+                      <a:round/>
+                      <a:headEnd type="none" w="med" len="med"/>
+                      <a:tailEnd type="none" w="med" len="med"/>
+                    </a:lnR>
+                    <a:lnT w="9525" cap="flat" cmpd="sng" algn="ctr">
+                      <a:solidFill>
+                        <a:srgbClr val="D4CFC8"/>
+                      </a:solidFill>
+                      <a:prstDash val="solid"/>
+                      <a:round/>
+                      <a:headEnd type="none" w="med" len="med"/>
+                      <a:tailEnd type="none" w="med" len="med"/>
+                    </a:lnT>
+                    <a:lnB w="9525" cap="flat" cmpd="sng" algn="ctr">
+                      <a:solidFill>
+                        <a:srgbClr val="D4CFC8"/>
+                      </a:solidFill>
+                      <a:prstDash val="solid"/>
+                      <a:round/>
+                      <a:headEnd type="none" w="med" len="med"/>
+                      <a:tailEnd type="none" w="med" len="med"/>
+                    </a:lnB>
+                    <a:solidFill>
+                      <a:srgbClr val="F7F4EF"/>
+                    </a:solidFill>
+                  </a:tcPr>
+                </a:tc>
+              </a:tr>
+              <a:tr h="228600">
+                <a:tc>
+                  <a:txBody>
+                    <a:bodyPr/>
+                    <a:lstStyle/>
+                    <a:p>
+                      <a:pPr algn="ctr" indent="0" marL="0">
+                        <a:buNone/>
+                      </a:pPr>
+                      <a:r>
+                        <a:rPr lang="en-US" sz="1200" b="1" dirty="0">
+                          <a:solidFill>
+                            <a:srgbClr val="8B1A1A"/>
+                          </a:solidFill>
+                        </a:rPr>
+                        <a:t>Nishan Paul</a:t>
+                      </a:r>
+                      <a:endParaRPr lang="en-US" sz="1200" dirty="0"/>
+                    </a:p>
+                  </a:txBody>
+                  <a:tcPr marL="91440" marR="91440" marT="45720" marB="45720" anchor="ctr">
+                    <a:lnL w="9525" cap="flat" cmpd="sng" algn="ctr">
+                      <a:solidFill>
+                        <a:srgbClr val="D4CFC8"/>
+                      </a:solidFill>
+                      <a:prstDash val="solid"/>
+                      <a:round/>
+                      <a:headEnd type="none" w="med" len="med"/>
+                      <a:tailEnd type="none" w="med" len="med"/>
+                    </a:lnL>
+                    <a:lnR w="9525" cap="flat" cmpd="sng" algn="ctr">
+                      <a:solidFill>
+                        <a:srgbClr val="D4CFC8"/>
+                      </a:solidFill>
+                      <a:prstDash val="solid"/>
+                      <a:round/>
+                      <a:headEnd type="none" w="med" len="med"/>
+                      <a:tailEnd type="none" w="med" len="med"/>
+                    </a:lnR>
+                    <a:lnT w="9525" cap="flat" cmpd="sng" algn="ctr">
+                      <a:solidFill>
+                        <a:srgbClr val="D4CFC8"/>
+                      </a:solidFill>
+                      <a:prstDash val="solid"/>
+                      <a:round/>
+                      <a:headEnd type="none" w="med" len="med"/>
+                      <a:tailEnd type="none" w="med" len="med"/>
+                    </a:lnT>
+                    <a:lnB w="9525" cap="flat" cmpd="sng" algn="ctr">
+                      <a:solidFill>
+                        <a:srgbClr val="D4CFC8"/>
+                      </a:solidFill>
+                      <a:prstDash val="solid"/>
+                      <a:round/>
+                      <a:headEnd type="none" w="med" len="med"/>
+                      <a:tailEnd type="none" w="med" len="med"/>
+                    </a:lnB>
+                  </a:tcPr>
+                </a:tc>
+                <a:tc>
+                  <a:txBody>
+                    <a:bodyPr/>
+                    <a:lstStyle/>
+                    <a:p>
+                      <a:pPr algn="ctr" indent="0" marL="0">
+                        <a:buNone/>
+                      </a:pPr>
+                      <a:r>
+                        <a:rPr lang="en-US" sz="1200" dirty="0">
+                          <a:solidFill>
+                            <a:srgbClr val="1A1A2E"/>
+                          </a:solidFill>
+                        </a:rPr>
+                        <a:t>50028</a:t>
+                      </a:r>
+                      <a:endParaRPr lang="en-US" sz="1200" dirty="0"/>
+                    </a:p>
+                  </a:txBody>
+                  <a:tcPr marL="91440" marR="91440" marT="45720" marB="45720" anchor="ctr">
+                    <a:lnL w="9525" cap="flat" cmpd="sng" algn="ctr">
+                      <a:solidFill>
+                        <a:srgbClr val="D4CFC8"/>
+                      </a:solidFill>
+                      <a:prstDash val="solid"/>
+                      <a:round/>
+                      <a:headEnd type="none" w="med" len="med"/>
+                      <a:tailEnd type="none" w="med" len="med"/>
+                    </a:lnL>
+                    <a:lnR w="9525" cap="flat" cmpd="sng" algn="ctr">
+                      <a:solidFill>
+                        <a:srgbClr val="D4CFC8"/>
+                      </a:solidFill>
+                      <a:prstDash val="solid"/>
+                      <a:round/>
+                      <a:headEnd type="none" w="med" len="med"/>
+                      <a:tailEnd type="none" w="med" len="med"/>
+                    </a:lnR>
+                    <a:lnT w="9525" cap="flat" cmpd="sng" algn="ctr">
+                      <a:solidFill>
+                        <a:srgbClr val="D4CFC8"/>
+                      </a:solidFill>
+                      <a:prstDash val="solid"/>
+                      <a:round/>
+                      <a:headEnd type="none" w="med" len="med"/>
+                      <a:tailEnd type="none" w="med" len="med"/>
+                    </a:lnT>
+                    <a:lnB w="9525" cap="flat" cmpd="sng" algn="ctr">
+                      <a:solidFill>
+                        <a:srgbClr val="D4CFC8"/>
+                      </a:solidFill>
+                      <a:prstDash val="solid"/>
+                      <a:round/>
+                      <a:headEnd type="none" w="med" len="med"/>
+                      <a:tailEnd type="none" w="med" len="med"/>
+                    </a:lnB>
+                  </a:tcPr>
+                </a:tc>
+                <a:tc>
+                  <a:txBody>
+                    <a:bodyPr/>
+                    <a:lstStyle/>
+                    <a:p>
+                      <a:pPr algn="ctr" indent="0" marL="0">
+                        <a:buNone/>
+                      </a:pPr>
+                      <a:r>
+                        <a:rPr lang="en-US" sz="1200" dirty="0">
+                          <a:solidFill>
+                            <a:srgbClr val="1A1A2E"/>
+                          </a:solidFill>
+                        </a:rPr>
+                        <a:t>H-55</a:t>
+                      </a:r>
+                      <a:endParaRPr lang="en-US" sz="1200" dirty="0"/>
+                    </a:p>
+                  </a:txBody>
+                  <a:tcPr marL="91440" marR="91440" marT="45720" marB="45720" anchor="ctr">
+                    <a:lnL w="9525" cap="flat" cmpd="sng" algn="ctr">
+                      <a:solidFill>
+                        <a:srgbClr val="D4CFC8"/>
+                      </a:solidFill>
+                      <a:prstDash val="solid"/>
+                      <a:round/>
+                      <a:headEnd type="none" w="med" len="med"/>
+                      <a:tailEnd type="none" w="med" len="med"/>
+                    </a:lnL>
+                    <a:lnR w="9525" cap="flat" cmpd="sng" algn="ctr">
+                      <a:solidFill>
+                        <a:srgbClr val="D4CFC8"/>
+                      </a:solidFill>
+                      <a:prstDash val="solid"/>
+                      <a:round/>
+                      <a:headEnd type="none" w="med" len="med"/>
+                      <a:tailEnd type="none" w="med" len="med"/>
+                    </a:lnR>
+                    <a:lnT w="9525" cap="flat" cmpd="sng" algn="ctr">
+                      <a:solidFill>
+                        <a:srgbClr val="D4CFC8"/>
+                      </a:solidFill>
+                      <a:prstDash val="solid"/>
+                      <a:round/>
+                      <a:headEnd type="none" w="med" len="med"/>
+                      <a:tailEnd type="none" w="med" len="med"/>
+                    </a:lnT>
+                    <a:lnB w="9525" cap="flat" cmpd="sng" algn="ctr">
+                      <a:solidFill>
+                        <a:srgbClr val="D4CFC8"/>
+                      </a:solidFill>
+                      <a:prstDash val="solid"/>
+                      <a:round/>
+                      <a:headEnd type="none" w="med" len="med"/>
+                      <a:tailEnd type="none" w="med" len="med"/>
+                    </a:lnB>
+                  </a:tcPr>
+                </a:tc>
+              </a:tr>
+              <a:tr h="228600">
+                <a:tc>
+                  <a:txBody>
+                    <a:bodyPr/>
+                    <a:lstStyle/>
+                    <a:p>
+                      <a:pPr algn="ctr" indent="0" marL="0">
+                        <a:buNone/>
+                      </a:pPr>
+                      <a:r>
+                        <a:rPr lang="en-US" sz="1200" b="1" dirty="0">
+                          <a:solidFill>
+                            <a:srgbClr val="8B1A1A"/>
+                          </a:solidFill>
+                        </a:rPr>
+                        <a:t>Md Rakibur Rahman</a:t>
+                      </a:r>
+                      <a:endParaRPr lang="en-US" sz="1200" dirty="0"/>
+                    </a:p>
+                  </a:txBody>
+                  <a:tcPr marL="91440" marR="91440" marT="45720" marB="45720" anchor="ctr">
+                    <a:lnL w="9525" cap="flat" cmpd="sng" algn="ctr">
+                      <a:solidFill>
+                        <a:srgbClr val="D4CFC8"/>
+                      </a:solidFill>
+                      <a:prstDash val="solid"/>
+                      <a:round/>
+                      <a:headEnd type="none" w="med" len="med"/>
+                      <a:tailEnd type="none" w="med" len="med"/>
+                    </a:lnL>
+                    <a:lnR w="9525" cap="flat" cmpd="sng" algn="ctr">
+                      <a:solidFill>
+                        <a:srgbClr val="D4CFC8"/>
+                      </a:solidFill>
+                      <a:prstDash val="solid"/>
+                      <a:round/>
+                      <a:headEnd type="none" w="med" len="med"/>
+                      <a:tailEnd type="none" w="med" len="med"/>
+                    </a:lnR>
+                    <a:lnT w="9525" cap="flat" cmpd="sng" algn="ctr">
+                      <a:solidFill>
+                        <a:srgbClr val="D4CFC8"/>
+                      </a:solidFill>
+                      <a:prstDash val="solid"/>
+                      <a:round/>
+                      <a:headEnd type="none" w="med" len="med"/>
+                      <a:tailEnd type="none" w="med" len="med"/>
+                    </a:lnT>
+                    <a:lnB w="9525" cap="flat" cmpd="sng" algn="ctr">
+                      <a:solidFill>
+                        <a:srgbClr val="D4CFC8"/>
+                      </a:solidFill>
+                      <a:prstDash val="solid"/>
+                      <a:round/>
+                      <a:headEnd type="none" w="med" len="med"/>
+                      <a:tailEnd type="none" w="med" len="med"/>
+                    </a:lnB>
+                  </a:tcPr>
+                </a:tc>
+                <a:tc>
+                  <a:txBody>
+                    <a:bodyPr/>
+                    <a:lstStyle/>
+                    <a:p>
+                      <a:pPr algn="ctr" indent="0" marL="0">
+                        <a:buNone/>
+                      </a:pPr>
+                      <a:r>
+                        <a:rPr lang="en-US" sz="1200" dirty="0">
+                          <a:solidFill>
+                            <a:srgbClr val="1A1A2E"/>
+                          </a:solidFill>
+                        </a:rPr>
+                        <a:t>50040</a:t>
+                      </a:r>
+                      <a:endParaRPr lang="en-US" sz="1200" dirty="0"/>
+                    </a:p>
+                  </a:txBody>
+                  <a:tcPr marL="91440" marR="91440" marT="45720" marB="45720" anchor="ctr">
+                    <a:lnL w="9525" cap="flat" cmpd="sng" algn="ctr">
+                      <a:solidFill>
+                        <a:srgbClr val="D4CFC8"/>
+                      </a:solidFill>
+                      <a:prstDash val="solid"/>
+                      <a:round/>
+                      <a:headEnd type="none" w="med" len="med"/>
+                      <a:tailEnd type="none" w="med" len="med"/>
+                    </a:lnL>
+                    <a:lnR w="9525" cap="flat" cmpd="sng" algn="ctr">
+                      <a:solidFill>
+                        <a:srgbClr val="D4CFC8"/>
+                      </a:solidFill>
+                      <a:prstDash val="solid"/>
+                      <a:round/>
+                      <a:headEnd type="none" w="med" len="med"/>
+                      <a:tailEnd type="none" w="med" len="med"/>
+                    </a:lnR>
+                    <a:lnT w="9525" cap="flat" cmpd="sng" algn="ctr">
+                      <a:solidFill>
+                        <a:srgbClr val="D4CFC8"/>
+                      </a:solidFill>
+                      <a:prstDash val="solid"/>
+                      <a:round/>
+                      <a:headEnd type="none" w="med" len="med"/>
+                      <a:tailEnd type="none" w="med" len="med"/>
+                    </a:lnT>
+                    <a:lnB w="9525" cap="flat" cmpd="sng" algn="ctr">
+                      <a:solidFill>
+                        <a:srgbClr val="D4CFC8"/>
+                      </a:solidFill>
+                      <a:prstDash val="solid"/>
+                      <a:round/>
+                      <a:headEnd type="none" w="med" len="med"/>
+                      <a:tailEnd type="none" w="med" len="med"/>
+                    </a:lnB>
+                  </a:tcPr>
+                </a:tc>
+                <a:tc>
+                  <a:txBody>
+                    <a:bodyPr/>
+                    <a:lstStyle/>
+                    <a:p>
+                      <a:pPr algn="ctr" indent="0" marL="0">
+                        <a:buNone/>
+                      </a:pPr>
+                      <a:r>
+                        <a:rPr lang="en-US" sz="1200" dirty="0">
+                          <a:solidFill>
+                            <a:srgbClr val="1A1A2E"/>
+                          </a:solidFill>
+                        </a:rPr>
+                        <a:t>H-49</a:t>
+                      </a:r>
+                      <a:endParaRPr lang="en-US" sz="1200" dirty="0"/>
+                    </a:p>
+                  </a:txBody>
+                  <a:tcPr marL="91440" marR="91440" marT="45720" marB="45720" anchor="ctr">
+                    <a:lnL w="9525" cap="flat" cmpd="sng" algn="ctr">
+                      <a:solidFill>
+                        <a:srgbClr val="D4CFC8"/>
+                      </a:solidFill>
+                      <a:prstDash val="solid"/>
+                      <a:round/>
+                      <a:headEnd type="none" w="med" len="med"/>
+                      <a:tailEnd type="none" w="med" len="med"/>
+                    </a:lnL>
+                    <a:lnR w="9525" cap="flat" cmpd="sng" algn="ctr">
+                      <a:solidFill>
+                        <a:srgbClr val="D4CFC8"/>
+                      </a:solidFill>
+                      <a:prstDash val="solid"/>
+                      <a:round/>
+                      <a:headEnd type="none" w="med" len="med"/>
+                      <a:tailEnd type="none" w="med" len="med"/>
+                    </a:lnR>
+                    <a:lnT w="9525" cap="flat" cmpd="sng" algn="ctr">
+                      <a:solidFill>
+                        <a:srgbClr val="D4CFC8"/>
+                      </a:solidFill>
+                      <a:prstDash val="solid"/>
+                      <a:round/>
+                      <a:headEnd type="none" w="med" len="med"/>
+                      <a:tailEnd type="none" w="med" len="med"/>
+                    </a:lnT>
+                    <a:lnB w="9525" cap="flat" cmpd="sng" algn="ctr">
+                      <a:solidFill>
+                        <a:srgbClr val="D4CFC8"/>
+                      </a:solidFill>
+                      <a:prstDash val="solid"/>
+                      <a:round/>
+                      <a:headEnd type="none" w="med" len="med"/>
+                      <a:tailEnd type="none" w="med" len="med"/>
+                    </a:lnB>
+                  </a:tcPr>
+                </a:tc>
+              </a:tr>
+            </a:tbl>
+          </a:graphicData>
+        </a:graphic>
+      </p:graphicFrame>
+      <p:sp>
+        <p:nvSpPr>
+          <p:cNvPr id="13" name="Shape 9"/>
+          <p:cNvSpPr/>
+          <p:nvPr/>
+        </p:nvSpPr>
+        <p:spPr>
+          <a:xfrm>
+            <a:off x="4381500" y="5114925"/>
+            <a:ext cx="3429000" cy="1524000"/>
+          </a:xfrm>
+          <a:prstGeom prst="rect">
+            <a:avLst/>
+          </a:prstGeom>
+          <a:solidFill>
+            <a:srgbClr val="EFEBE3"/>
+          </a:solidFill>
+          <a:ln/>
+          <a:effectLst>
+            <a:outerShdw sx="100000" sy="100000" kx="0" ky="0" algn="bl" rotWithShape="0" blurRad="76200" dist="38100" dir="5400000">
+              <a:srgbClr val="000000">
+                <a:alpha val="5000"/>
+              </a:srgbClr>
+            </a:outerShdw>
+          </a:effectLst>
+        </p:spPr>
+      </p:sp>
+      <p:sp>
+        <p:nvSpPr>
+          <p:cNvPr id="14" name="Shape 10"/>
+          <p:cNvSpPr/>
+          <p:nvPr/>
+        </p:nvSpPr>
+        <p:spPr>
+          <a:xfrm>
+            <a:off x="4381500" y="5114925"/>
+            <a:ext cx="3429000" cy="28575"/>
+          </a:xfrm>
+          <a:prstGeom prst="rect">
+            <a:avLst/>
+          </a:prstGeom>
+          <a:solidFill>
+            <a:srgbClr val="2E4A7A"/>
+          </a:solidFill>
+          <a:ln/>
+        </p:spPr>
+      </p:sp>
+      <p:sp>
+        <p:nvSpPr>
+          <p:cNvPr id="15" name="Text 11"/>
+          <p:cNvSpPr txBox="1"/>
+          <p:nvPr/>
+        </p:nvSpPr>
+        <p:spPr>
+          <a:xfrm>
+            <a:off x="4381500" y="5305425"/>
+            <a:ext cx="3429000" cy="133350"/>
+          </a:xfrm>
+          <a:prstGeom prst="rect">
+            <a:avLst/>
+          </a:prstGeom>
+          <a:noFill/>
+          <a:ln/>
+        </p:spPr>
+        <p:txBody>
+          <a:bodyPr wrap="square" lIns="0" tIns="0" rIns="0" bIns="0" rtlCol="0" anchor="ctr"/>
+          <a:lstStyle/>
+          <a:p>
+            <a:pPr algn="ctr" indent="0" marL="0">
+              <a:buNone/>
+            </a:pPr>
+            <a:r>
+              <a:rPr lang="en-US" sz="900" b="1" spc="150" kern="0" dirty="0">
+                <a:solidFill>
+                  <a:srgbClr val="2E4A7A"/>
+                </a:solidFill>
+                <a:latin typeface="Calibri" pitchFamily="34" charset="0"/>
+                <a:ea typeface="Calibri" pitchFamily="34" charset="-122"/>
+                <a:cs typeface="Calibri" pitchFamily="34" charset="-120"/>
+              </a:rPr>
+              <a:t>SUPERVISOR</a:t>
+            </a:r>
+            <a:endParaRPr lang="en-US" sz="900" dirty="0"/>
+          </a:p>
+        </p:txBody>
+      </p:sp>
+      <p:sp>
+        <p:nvSpPr>
+          <p:cNvPr id="16" name="Text 12"/>
+          <p:cNvSpPr txBox="1"/>
+          <p:nvPr/>
+        </p:nvSpPr>
+        <p:spPr>
+          <a:xfrm>
+            <a:off x="4381500" y="5553075"/>
+            <a:ext cx="3429000" cy="247650"/>
+          </a:xfrm>
+          <a:prstGeom prst="rect">
+            <a:avLst/>
+          </a:prstGeom>
+          <a:noFill/>
+          <a:ln/>
+        </p:spPr>
+        <p:txBody>
+          <a:bodyPr wrap="square" lIns="0" tIns="0" rIns="0" bIns="0" rtlCol="0" anchor="ctr"/>
+          <a:lstStyle/>
+          <a:p>
+            <a:pPr algn="ctr" indent="0" marL="0">
+              <a:buNone/>
+            </a:pPr>
+            <a:r>
+              <a:rPr lang="en-US" sz="1800" b="1" dirty="0">
+                <a:solidFill>
+                  <a:srgbClr val="1A1A2E"/>
+                </a:solidFill>
+                <a:latin typeface="Cambria" pitchFamily="34" charset="0"/>
+                <a:ea typeface="Cambria" pitchFamily="34" charset="-122"/>
+                <a:cs typeface="Cambria" pitchFamily="34" charset="-120"/>
+              </a:rPr>
+              <a:t>Dr. Md. Abdur Razzaque</a:t>
+            </a:r>
+            <a:endParaRPr lang="en-US" sz="1800" dirty="0"/>
+          </a:p>
+        </p:txBody>
+      </p:sp>
+      <p:sp>
+        <p:nvSpPr>
+          <p:cNvPr id="17" name="Text 13"/>
+          <p:cNvSpPr txBox="1"/>
+          <p:nvPr/>
+        </p:nvSpPr>
+        <p:spPr>
+          <a:xfrm>
+            <a:off x="4381500" y="5857875"/>
+            <a:ext cx="3429000" cy="152400"/>
+          </a:xfrm>
+          <a:prstGeom prst="rect">
+            <a:avLst/>
+          </a:prstGeom>
+          <a:noFill/>
+          <a:ln/>
+        </p:spPr>
+        <p:txBody>
+          <a:bodyPr wrap="square" lIns="0" tIns="0" rIns="0" bIns="0" rtlCol="0" anchor="ctr"/>
+          <a:lstStyle/>
+          <a:p>
+            <a:pPr algn="ctr" indent="0" marL="0">
+              <a:buNone/>
+            </a:pPr>
+            <a:r>
+              <a:rPr lang="en-US" sz="1100" b="1" dirty="0">
+                <a:solidFill>
+                  <a:srgbClr val="2E4A7A"/>
+                </a:solidFill>
+                <a:latin typeface="Calibri" pitchFamily="34" charset="0"/>
+                <a:ea typeface="Calibri" pitchFamily="34" charset="-122"/>
+                <a:cs typeface="Calibri" pitchFamily="34" charset="-120"/>
+              </a:rPr>
+              <a:t>Professor and Chair</a:t>
+            </a:r>
+            <a:endParaRPr lang="en-US" sz="1100" dirty="0"/>
+          </a:p>
+        </p:txBody>
+      </p:sp>
+      <p:sp>
+        <p:nvSpPr>
+          <p:cNvPr id="18" name="Text 14"/>
+          <p:cNvSpPr txBox="1"/>
+          <p:nvPr/>
+        </p:nvSpPr>
+        <p:spPr>
+          <a:xfrm>
+            <a:off x="4381500" y="6067425"/>
+            <a:ext cx="3429000" cy="152400"/>
+          </a:xfrm>
+          <a:prstGeom prst="rect">
+            <a:avLst/>
+          </a:prstGeom>
+          <a:noFill/>
+          <a:ln/>
+        </p:spPr>
+        <p:txBody>
+          <a:bodyPr wrap="square" lIns="0" tIns="0" rIns="0" bIns="0" rtlCol="0" anchor="ctr"/>
+          <a:lstStyle/>
+          <a:p>
+            <a:pPr algn="ctr" indent="0" marL="0">
+              <a:buNone/>
+            </a:pPr>
+            <a:r>
+              <a:rPr lang="en-US" sz="1050" dirty="0">
+                <a:solidFill>
+                  <a:srgbClr val="1A1A2E"/>
+                </a:solidFill>
+                <a:latin typeface="Calibri" pitchFamily="34" charset="0"/>
+                <a:ea typeface="Calibri" pitchFamily="34" charset="-122"/>
+                <a:cs typeface="Calibri" pitchFamily="34" charset="-120"/>
+              </a:rPr>
+              <a:t>Department of Computer Science and Engineering</a:t>
+            </a:r>
+            <a:endParaRPr lang="en-US" sz="1050" dirty="0"/>
+          </a:p>
+        </p:txBody>
+      </p:sp>
+      <p:sp>
+        <p:nvSpPr>
+          <p:cNvPr id="19" name="Text 15"/>
+          <p:cNvSpPr txBox="1"/>
+          <p:nvPr/>
+        </p:nvSpPr>
+        <p:spPr>
+          <a:xfrm>
+            <a:off x="4381500" y="6257925"/>
+            <a:ext cx="3429000" cy="133350"/>
+          </a:xfrm>
+          <a:prstGeom prst="rect">
+            <a:avLst/>
+          </a:prstGeom>
+          <a:noFill/>
+          <a:ln/>
+        </p:spPr>
+        <p:txBody>
+          <a:bodyPr wrap="square" lIns="0" tIns="0" rIns="0" bIns="0" rtlCol="0" anchor="ctr"/>
+          <a:lstStyle/>
+          <a:p>
+            <a:pPr algn="ctr" indent="0" marL="0">
+              <a:buNone/>
+            </a:pPr>
+            <a:r>
+              <a:rPr lang="en-US" sz="900" b="1" spc="80" kern="0" dirty="0">
+                <a:solidFill>
+                  <a:srgbClr val="2E4A7A"/>
+                </a:solidFill>
+                <a:latin typeface="Calibri" pitchFamily="34" charset="0"/>
+                <a:ea typeface="Calibri" pitchFamily="34" charset="-122"/>
+                <a:cs typeface="Calibri" pitchFamily="34" charset="-120"/>
+              </a:rPr>
+              <a:t>UNIVERSITY OF DHAKA</a:t>
+            </a:r>
+            <a:endParaRPr lang="en-US" sz="900" dirty="0"/>
+          </a:p>
+        </p:txBody>
+      </p:sp>
     </p:spTree>
   </p:cSld>
   <p:clrMapOvr>

</xml_diff>